<commit_message>
update manually created figures
</commit_message>
<xml_diff>
--- a/Materials/Figures within article/study design basal attributes_wide.pptx
+++ b/Materials/Figures within article/study design basal attributes_wide.pptx
@@ -243,7 +243,7 @@
           <a:p>
             <a:fld id="{24188342-571A-6841-AC1D-E620118845AD}" type="datetimeFigureOut">
               <a:rPr lang="en-US" smtClean="0"/>
-              <a:t>7/19/2024</a:t>
+              <a:t>4/3/2025</a:t>
             </a:fld>
             <a:endParaRPr lang="en-US"/>
           </a:p>
@@ -413,7 +413,7 @@
           <a:p>
             <a:fld id="{24188342-571A-6841-AC1D-E620118845AD}" type="datetimeFigureOut">
               <a:rPr lang="en-US" smtClean="0"/>
-              <a:t>7/19/2024</a:t>
+              <a:t>4/3/2025</a:t>
             </a:fld>
             <a:endParaRPr lang="en-US"/>
           </a:p>
@@ -593,7 +593,7 @@
           <a:p>
             <a:fld id="{24188342-571A-6841-AC1D-E620118845AD}" type="datetimeFigureOut">
               <a:rPr lang="en-US" smtClean="0"/>
-              <a:t>7/19/2024</a:t>
+              <a:t>4/3/2025</a:t>
             </a:fld>
             <a:endParaRPr lang="en-US"/>
           </a:p>
@@ -763,7 +763,7 @@
           <a:p>
             <a:fld id="{24188342-571A-6841-AC1D-E620118845AD}" type="datetimeFigureOut">
               <a:rPr lang="en-US" smtClean="0"/>
-              <a:t>7/19/2024</a:t>
+              <a:t>4/3/2025</a:t>
             </a:fld>
             <a:endParaRPr lang="en-US"/>
           </a:p>
@@ -1007,7 +1007,7 @@
           <a:p>
             <a:fld id="{24188342-571A-6841-AC1D-E620118845AD}" type="datetimeFigureOut">
               <a:rPr lang="en-US" smtClean="0"/>
-              <a:t>7/19/2024</a:t>
+              <a:t>4/3/2025</a:t>
             </a:fld>
             <a:endParaRPr lang="en-US"/>
           </a:p>
@@ -1239,7 +1239,7 @@
           <a:p>
             <a:fld id="{24188342-571A-6841-AC1D-E620118845AD}" type="datetimeFigureOut">
               <a:rPr lang="en-US" smtClean="0"/>
-              <a:t>7/19/2024</a:t>
+              <a:t>4/3/2025</a:t>
             </a:fld>
             <a:endParaRPr lang="en-US"/>
           </a:p>
@@ -1606,7 +1606,7 @@
           <a:p>
             <a:fld id="{24188342-571A-6841-AC1D-E620118845AD}" type="datetimeFigureOut">
               <a:rPr lang="en-US" smtClean="0"/>
-              <a:t>7/19/2024</a:t>
+              <a:t>4/3/2025</a:t>
             </a:fld>
             <a:endParaRPr lang="en-US"/>
           </a:p>
@@ -1724,7 +1724,7 @@
           <a:p>
             <a:fld id="{24188342-571A-6841-AC1D-E620118845AD}" type="datetimeFigureOut">
               <a:rPr lang="en-US" smtClean="0"/>
-              <a:t>7/19/2024</a:t>
+              <a:t>4/3/2025</a:t>
             </a:fld>
             <a:endParaRPr lang="en-US"/>
           </a:p>
@@ -1819,7 +1819,7 @@
           <a:p>
             <a:fld id="{24188342-571A-6841-AC1D-E620118845AD}" type="datetimeFigureOut">
               <a:rPr lang="en-US" smtClean="0"/>
-              <a:t>7/19/2024</a:t>
+              <a:t>4/3/2025</a:t>
             </a:fld>
             <a:endParaRPr lang="en-US"/>
           </a:p>
@@ -2096,7 +2096,7 @@
           <a:p>
             <a:fld id="{24188342-571A-6841-AC1D-E620118845AD}" type="datetimeFigureOut">
               <a:rPr lang="en-US" smtClean="0"/>
-              <a:t>7/19/2024</a:t>
+              <a:t>4/3/2025</a:t>
             </a:fld>
             <a:endParaRPr lang="en-US"/>
           </a:p>
@@ -2353,7 +2353,7 @@
           <a:p>
             <a:fld id="{24188342-571A-6841-AC1D-E620118845AD}" type="datetimeFigureOut">
               <a:rPr lang="en-US" smtClean="0"/>
-              <a:t>7/19/2024</a:t>
+              <a:t>4/3/2025</a:t>
             </a:fld>
             <a:endParaRPr lang="en-US"/>
           </a:p>
@@ -2566,7 +2566,7 @@
           <a:p>
             <a:fld id="{24188342-571A-6841-AC1D-E620118845AD}" type="datetimeFigureOut">
               <a:rPr lang="en-US" smtClean="0"/>
-              <a:t>7/19/2024</a:t>
+              <a:t>4/3/2025</a:t>
             </a:fld>
             <a:endParaRPr lang="en-US"/>
           </a:p>
@@ -3016,7 +3016,7 @@
         <p:spPr>
           <a:xfrm>
             <a:off x="1334845" y="155054"/>
-            <a:ext cx="6895933" cy="338554"/>
+            <a:ext cx="6895933" cy="369332"/>
           </a:xfrm>
           <a:prstGeom prst="rect">
             <a:avLst/>
@@ -3036,7 +3036,7 @@
           <a:p>
             <a:pPr algn="ctr"/>
             <a:r>
-              <a:rPr lang="en-US" sz="1600" b="1" dirty="0">
+              <a:rPr lang="en-US" b="1" dirty="0">
                 <a:latin typeface="Times New Roman" panose="02020603050405020304" pitchFamily="18" charset="0"/>
                 <a:ea typeface="Yu Gothic" panose="020B0400000000000000" pitchFamily="34" charset="-128"/>
                 <a:cs typeface="Times New Roman" panose="02020603050405020304" pitchFamily="18" charset="0"/>
@@ -3098,7 +3098,7 @@
         </p:blipFill>
         <p:spPr>
           <a:xfrm>
-            <a:off x="357171" y="1294763"/>
+            <a:off x="357174" y="1397088"/>
             <a:ext cx="675301" cy="601721"/>
           </a:xfrm>
           <a:prstGeom prst="rect">
@@ -3158,7 +3158,7 @@
         </p:blipFill>
         <p:spPr>
           <a:xfrm>
-            <a:off x="4605968" y="1253649"/>
+            <a:off x="4630255" y="1438550"/>
             <a:ext cx="675301" cy="642834"/>
           </a:xfrm>
           <a:prstGeom prst="rect">
@@ -3215,7 +3215,7 @@
         </p:nvSpPr>
         <p:spPr>
           <a:xfrm>
-            <a:off x="1069604" y="1294532"/>
+            <a:off x="1069607" y="1396857"/>
             <a:ext cx="3028056" cy="584775"/>
           </a:xfrm>
           <a:prstGeom prst="rect">
@@ -3285,7 +3285,7 @@
         </p:nvSpPr>
         <p:spPr>
           <a:xfrm>
-            <a:off x="5305556" y="1372371"/>
+            <a:off x="5305556" y="1373055"/>
             <a:ext cx="3443122" cy="830997"/>
           </a:xfrm>
           <a:prstGeom prst="rect">
@@ -3458,7 +3458,7 @@
         <p:spPr>
           <a:xfrm>
             <a:off x="3236378" y="2884801"/>
-            <a:ext cx="2208072" cy="819410"/>
+            <a:ext cx="2161225" cy="494663"/>
           </a:xfrm>
           <a:prstGeom prst="rightArrow">
             <a:avLst/>
@@ -3503,7 +3503,7 @@
         </p:nvSpPr>
         <p:spPr>
           <a:xfrm>
-            <a:off x="3106413" y="3692249"/>
+            <a:off x="3120416" y="3578863"/>
             <a:ext cx="2999110" cy="1077218"/>
           </a:xfrm>
           <a:prstGeom prst="rect">
@@ -3625,52 +3625,6 @@
               <a:rPr lang="en-US" sz="1600" dirty="0"/>
               <a:t>Applied LLMs to create textual descriptions of future material systems using identified clusters</a:t>
             </a:r>
-          </a:p>
-        </p:txBody>
-      </p:sp>
-      <p:sp>
-        <p:nvSpPr>
-          <p:cNvPr id="49" name="Pfeil: nach rechts 48">
-            <a:extLst>
-              <a:ext uri="{FF2B5EF4-FFF2-40B4-BE49-F238E27FC236}">
-                <a16:creationId xmlns:a16="http://schemas.microsoft.com/office/drawing/2014/main" id="{CC291992-4353-4468-A984-43554F359075}"/>
-              </a:ext>
-            </a:extLst>
-          </p:cNvPr>
-          <p:cNvSpPr/>
-          <p:nvPr/>
-        </p:nvSpPr>
-        <p:spPr>
-          <a:xfrm>
-            <a:off x="2176463" y="6028906"/>
-            <a:ext cx="969530" cy="825149"/>
-          </a:xfrm>
-          <a:prstGeom prst="rightArrow">
-            <a:avLst/>
-          </a:prstGeom>
-        </p:spPr>
-        <p:style>
-          <a:lnRef idx="2">
-            <a:schemeClr val="dk1">
-              <a:shade val="50000"/>
-            </a:schemeClr>
-          </a:lnRef>
-          <a:fillRef idx="1">
-            <a:schemeClr val="dk1"/>
-          </a:fillRef>
-          <a:effectRef idx="0">
-            <a:schemeClr val="dk1"/>
-          </a:effectRef>
-          <a:fontRef idx="minor">
-            <a:schemeClr val="lt1"/>
-          </a:fontRef>
-        </p:style>
-        <p:txBody>
-          <a:bodyPr rtlCol="0" anchor="ctr"/>
-          <a:lstStyle/>
-          <a:p>
-            <a:pPr algn="ctr"/>
-            <a:endParaRPr lang="en-US" sz="1600"/>
           </a:p>
         </p:txBody>
       </p:sp>
@@ -4065,7 +4019,7 @@
         <p:spPr>
           <a:xfrm>
             <a:off x="1334844" y="2157212"/>
-            <a:ext cx="6895933" cy="338554"/>
+            <a:ext cx="6895933" cy="369332"/>
           </a:xfrm>
           <a:prstGeom prst="rect">
             <a:avLst/>
@@ -4085,7 +4039,7 @@
           <a:p>
             <a:pPr algn="ctr"/>
             <a:r>
-              <a:rPr lang="en-US" sz="1600" b="1" dirty="0">
+              <a:rPr lang="en-US" b="1" dirty="0">
                 <a:latin typeface="Times New Roman" panose="02020603050405020304" pitchFamily="18" charset="0"/>
                 <a:ea typeface="Yu Gothic" panose="020B0400000000000000" pitchFamily="34" charset="-128"/>
                 <a:cs typeface="Times New Roman" panose="02020603050405020304" pitchFamily="18" charset="0"/>
@@ -4110,7 +4064,7 @@
         <p:spPr>
           <a:xfrm>
             <a:off x="1334844" y="5150744"/>
-            <a:ext cx="6895933" cy="338554"/>
+            <a:ext cx="6895933" cy="369332"/>
           </a:xfrm>
           <a:prstGeom prst="rect">
             <a:avLst/>
@@ -4130,13 +4084,59 @@
           <a:p>
             <a:pPr algn="ctr"/>
             <a:r>
-              <a:rPr lang="en-US" sz="1600" b="1" dirty="0">
+              <a:rPr lang="en-US" b="1" dirty="0">
                 <a:latin typeface="Times New Roman" panose="02020603050405020304" pitchFamily="18" charset="0"/>
                 <a:ea typeface="Yu Gothic" panose="020B0400000000000000" pitchFamily="34" charset="-128"/>
                 <a:cs typeface="Times New Roman" panose="02020603050405020304" pitchFamily="18" charset="0"/>
               </a:rPr>
               <a:t>Part III: use LLMs to create textual descriptions</a:t>
             </a:r>
+          </a:p>
+        </p:txBody>
+      </p:sp>
+      <p:sp>
+        <p:nvSpPr>
+          <p:cNvPr id="39" name="Pfeil: nach rechts 38">
+            <a:extLst>
+              <a:ext uri="{FF2B5EF4-FFF2-40B4-BE49-F238E27FC236}">
+                <a16:creationId xmlns:a16="http://schemas.microsoft.com/office/drawing/2014/main" id="{40A44B92-4F5B-4C9C-B729-9E3593B403D6}"/>
+              </a:ext>
+            </a:extLst>
+          </p:cNvPr>
+          <p:cNvSpPr/>
+          <p:nvPr/>
+        </p:nvSpPr>
+        <p:spPr>
+          <a:xfrm>
+            <a:off x="2089817" y="5862521"/>
+            <a:ext cx="1276135" cy="494663"/>
+          </a:xfrm>
+          <a:prstGeom prst="rightArrow">
+            <a:avLst/>
+          </a:prstGeom>
+        </p:spPr>
+        <p:style>
+          <a:lnRef idx="2">
+            <a:schemeClr val="dk1">
+              <a:shade val="50000"/>
+            </a:schemeClr>
+          </a:lnRef>
+          <a:fillRef idx="1">
+            <a:schemeClr val="dk1"/>
+          </a:fillRef>
+          <a:effectRef idx="0">
+            <a:schemeClr val="dk1"/>
+          </a:effectRef>
+          <a:fontRef idx="minor">
+            <a:schemeClr val="lt1"/>
+          </a:fontRef>
+        </p:style>
+        <p:txBody>
+          <a:bodyPr rtlCol="0" anchor="ctr"/>
+          <a:lstStyle/>
+          <a:p>
+            <a:pPr algn="ctr"/>
+            <a:endParaRPr lang="en-US" sz="1600"/>
           </a:p>
         </p:txBody>
       </p:sp>

</xml_diff>